<commit_message>
Add team member names to deck and README; link repo and demo on closing slide
Co-Authored-By: Claude Opus 5.5 <noreply@anthropic.com>
</commit_message>
<xml_diff>
--- a/MSRIT_AlooParatha_Submission_ppt.pptx
+++ b/MSRIT_AlooParatha_Submission_ppt.pptx
@@ -3569,24 +3569,24 @@
         </p:nvSpPr>
         <p:spPr>
           <a:xfrm>
-            <a:off x="457200" y="4526280"/>
-            <a:ext cx="5486400" cy="274320"/>
-          </a:xfrm>
-          <a:prstGeom prst="rect">
-            <a:avLst/>
-          </a:prstGeom>
-          <a:noFill/>
-          <a:ln/>
-        </p:spPr>
-        <p:txBody>
-          <a:bodyPr wrap="square" lIns="0" tIns="0" rIns="0" bIns="0" rtlCol="0" anchor="t"/>
-          <a:lstStyle/>
-          <a:p>
-            <a:pPr indent="0" marL="0">
-              <a:buNone/>
-            </a:pPr>
-            <a:r>
-              <a:rPr lang="en-US" sz="1050" dirty="0">
+            <a:off x="457200" y="4224528"/>
+            <a:ext cx="5486400" cy="256032"/>
+          </a:xfrm>
+          <a:prstGeom prst="rect">
+            <a:avLst/>
+          </a:prstGeom>
+          <a:noFill/>
+          <a:ln/>
+        </p:spPr>
+        <p:txBody>
+          <a:bodyPr wrap="square" lIns="0" tIns="0" rIns="0" bIns="0" rtlCol="0" anchor="t"/>
+          <a:lstStyle/>
+          <a:p>
+            <a:pPr indent="0" marL="0">
+              <a:buNone/>
+            </a:pPr>
+            <a:r>
+              <a:rPr lang="en-US" sz="1150" b="1" dirty="0">
                 <a:solidFill>
                   <a:srgbClr val="F4F1EA"/>
                 </a:solidFill>
@@ -3594,15 +3594,54 @@
                 <a:ea typeface="Calibri" pitchFamily="34" charset="-122"/>
                 <a:cs typeface="Calibri" pitchFamily="34" charset="-120"/>
               </a:rPr>
+              <a:t>Shourya Chouhan  ·  Shreya Singh Chouhan  ·  Yash Mittal  ·  Vrunda Hatwar</a:t>
+            </a:r>
+            <a:endParaRPr lang="en-US" sz="1150" dirty="0"/>
+          </a:p>
+        </p:txBody>
+      </p:sp>
+      <p:sp>
+        <p:nvSpPr>
+          <p:cNvPr id="14" name="Text 12"/>
+          <p:cNvSpPr txBox="1"/>
+          <p:nvPr/>
+        </p:nvSpPr>
+        <p:spPr>
+          <a:xfrm>
+            <a:off x="457200" y="4526280"/>
+            <a:ext cx="5486400" cy="274320"/>
+          </a:xfrm>
+          <a:prstGeom prst="rect">
+            <a:avLst/>
+          </a:prstGeom>
+          <a:noFill/>
+          <a:ln/>
+        </p:spPr>
+        <p:txBody>
+          <a:bodyPr wrap="square" lIns="0" tIns="0" rIns="0" bIns="0" rtlCol="0" anchor="t"/>
+          <a:lstStyle/>
+          <a:p>
+            <a:pPr indent="0" marL="0">
+              <a:buNone/>
+            </a:pPr>
+            <a:r>
+              <a:rPr lang="en-US" sz="1000" dirty="0">
+                <a:solidFill>
+                  <a:srgbClr val="A8A091"/>
+                </a:solidFill>
+                <a:latin typeface="Calibri" pitchFamily="34" charset="0"/>
+                <a:ea typeface="Calibri" pitchFamily="34" charset="-122"/>
+                <a:cs typeface="Calibri" pitchFamily="34" charset="-120"/>
+              </a:rPr>
               <a:t>Team Aloo Paratha  ·  M S Ramaiah Institute of Technology (MSRIT), Bengaluru  ·  Theme ID 02</a:t>
             </a:r>
-            <a:endParaRPr lang="en-US" sz="1050" dirty="0"/>
-          </a:p>
-        </p:txBody>
-      </p:sp>
-      <p:sp>
-        <p:nvSpPr>
-          <p:cNvPr id="14" name="Shape 12"/>
+            <a:endParaRPr lang="en-US" sz="1000" dirty="0"/>
+          </a:p>
+        </p:txBody>
+      </p:sp>
+      <p:sp>
+        <p:nvSpPr>
+          <p:cNvPr id="15" name="Shape 13"/>
           <p:cNvSpPr/>
           <p:nvPr/>
         </p:nvSpPr>
@@ -3629,7 +3668,7 @@
       </p:sp>
       <p:sp>
         <p:nvSpPr>
-          <p:cNvPr id="15" name="Shape 13"/>
+          <p:cNvPr id="16" name="Shape 14"/>
           <p:cNvSpPr/>
           <p:nvPr/>
         </p:nvSpPr>
@@ -3651,7 +3690,7 @@
       </p:sp>
       <p:sp>
         <p:nvSpPr>
-          <p:cNvPr id="16" name="Shape 14"/>
+          <p:cNvPr id="17" name="Shape 15"/>
           <p:cNvSpPr/>
           <p:nvPr/>
         </p:nvSpPr>
@@ -3673,7 +3712,7 @@
       </p:sp>
       <p:sp>
         <p:nvSpPr>
-          <p:cNvPr id="17" name="Text 15"/>
+          <p:cNvPr id="18" name="Text 16"/>
           <p:cNvSpPr txBox="1"/>
           <p:nvPr/>
         </p:nvSpPr>
@@ -3726,7 +3765,7 @@
       </p:sp>
       <p:sp>
         <p:nvSpPr>
-          <p:cNvPr id="18" name="Shape 16"/>
+          <p:cNvPr id="19" name="Shape 17"/>
           <p:cNvSpPr/>
           <p:nvPr/>
         </p:nvSpPr>
@@ -3748,7 +3787,7 @@
       </p:sp>
       <p:sp>
         <p:nvSpPr>
-          <p:cNvPr id="19" name="Text 17"/>
+          <p:cNvPr id="20" name="Text 18"/>
           <p:cNvSpPr txBox="1"/>
           <p:nvPr/>
         </p:nvSpPr>
@@ -3787,7 +3826,7 @@
       </p:sp>
       <p:sp>
         <p:nvSpPr>
-          <p:cNvPr id="20" name="Text 18"/>
+          <p:cNvPr id="21" name="Text 19"/>
           <p:cNvSpPr txBox="1"/>
           <p:nvPr/>
         </p:nvSpPr>
@@ -3826,7 +3865,7 @@
       </p:sp>
       <p:sp>
         <p:nvSpPr>
-          <p:cNvPr id="21" name="Shape 19"/>
+          <p:cNvPr id="22" name="Shape 20"/>
           <p:cNvSpPr/>
           <p:nvPr/>
         </p:nvSpPr>
@@ -3853,7 +3892,7 @@
       </p:sp>
       <p:sp>
         <p:nvSpPr>
-          <p:cNvPr id="22" name="Text 20"/>
+          <p:cNvPr id="23" name="Text 21"/>
           <p:cNvSpPr txBox="1"/>
           <p:nvPr/>
         </p:nvSpPr>
@@ -3892,7 +3931,7 @@
       </p:sp>
       <p:sp>
         <p:nvSpPr>
-          <p:cNvPr id="23" name="Shape 21"/>
+          <p:cNvPr id="24" name="Shape 22"/>
           <p:cNvSpPr/>
           <p:nvPr/>
         </p:nvSpPr>
@@ -3914,7 +3953,7 @@
       </p:sp>
       <p:sp>
         <p:nvSpPr>
-          <p:cNvPr id="24" name="Text 22"/>
+          <p:cNvPr id="25" name="Text 23"/>
           <p:cNvSpPr txBox="1"/>
           <p:nvPr/>
         </p:nvSpPr>
@@ -3953,7 +3992,7 @@
       </p:sp>
       <p:sp>
         <p:nvSpPr>
-          <p:cNvPr id="25" name="Text 23"/>
+          <p:cNvPr id="26" name="Text 24"/>
           <p:cNvSpPr txBox="1"/>
           <p:nvPr/>
         </p:nvSpPr>
@@ -4026,7 +4065,7 @@
       </p:sp>
       <p:sp>
         <p:nvSpPr>
-          <p:cNvPr id="26" name="Shape 24"/>
+          <p:cNvPr id="27" name="Shape 25"/>
           <p:cNvSpPr/>
           <p:nvPr/>
         </p:nvSpPr>
@@ -4048,7 +4087,7 @@
       </p:sp>
       <p:sp>
         <p:nvSpPr>
-          <p:cNvPr id="27" name="Text 25"/>
+          <p:cNvPr id="28" name="Text 26"/>
           <p:cNvSpPr txBox="1"/>
           <p:nvPr/>
         </p:nvSpPr>
@@ -4087,7 +4126,7 @@
       </p:sp>
       <p:sp>
         <p:nvSpPr>
-          <p:cNvPr id="28" name="Shape 26"/>
+          <p:cNvPr id="29" name="Shape 27"/>
           <p:cNvSpPr/>
           <p:nvPr/>
         </p:nvSpPr>
@@ -4114,7 +4153,7 @@
       </p:sp>
       <p:sp>
         <p:nvSpPr>
-          <p:cNvPr id="29" name="Text 27"/>
+          <p:cNvPr id="30" name="Text 28"/>
           <p:cNvSpPr txBox="1"/>
           <p:nvPr/>
         </p:nvSpPr>
@@ -4153,7 +4192,7 @@
       </p:sp>
       <p:sp>
         <p:nvSpPr>
-          <p:cNvPr id="30" name="Shape 28"/>
+          <p:cNvPr id="31" name="Shape 29"/>
           <p:cNvSpPr/>
           <p:nvPr/>
         </p:nvSpPr>
@@ -4175,7 +4214,7 @@
       </p:sp>
       <p:sp>
         <p:nvSpPr>
-          <p:cNvPr id="31" name="Text 29"/>
+          <p:cNvPr id="32" name="Text 30"/>
           <p:cNvSpPr txBox="1"/>
           <p:nvPr/>
         </p:nvSpPr>
@@ -4214,7 +4253,7 @@
       </p:sp>
       <p:sp>
         <p:nvSpPr>
-          <p:cNvPr id="32" name="Text 30"/>
+          <p:cNvPr id="33" name="Text 31"/>
           <p:cNvSpPr txBox="1"/>
           <p:nvPr/>
         </p:nvSpPr>
@@ -4253,7 +4292,7 @@
       </p:sp>
       <p:sp>
         <p:nvSpPr>
-          <p:cNvPr id="33" name="Text 31"/>
+          <p:cNvPr id="34" name="Text 32"/>
           <p:cNvSpPr txBox="1"/>
           <p:nvPr/>
         </p:nvSpPr>
@@ -14248,7 +14287,7 @@
         </p:nvSpPr>
         <p:spPr>
           <a:xfrm>
-            <a:off x="457200" y="3931920"/>
+            <a:off x="457200" y="3840480"/>
             <a:ext cx="8229600" cy="274320"/>
           </a:xfrm>
           <a:prstGeom prst="rect">
@@ -14265,7 +14304,46 @@
               <a:buNone/>
             </a:pPr>
             <a:r>
-              <a:rPr lang="en-US" sz="1100" dirty="0">
+              <a:rPr lang="en-US" sz="1050" dirty="0">
+                <a:solidFill>
+                  <a:srgbClr val="FF5A1F"/>
+                </a:solidFill>
+                <a:latin typeface="Courier New" pitchFamily="34" charset="0"/>
+                <a:ea typeface="Courier New" pitchFamily="34" charset="-122"/>
+                <a:cs typeface="Courier New" pitchFamily="34" charset="-120"/>
+              </a:rPr>
+              <a:t>github.com/shouryez/onetap  (tag PRISM_GENAI_HACKATHON_Y2026)   ·   demo: youtu.be/oJ5d5VblRTA</a:t>
+            </a:r>
+            <a:endParaRPr lang="en-US" sz="1050" dirty="0"/>
+          </a:p>
+        </p:txBody>
+      </p:sp>
+      <p:sp>
+        <p:nvSpPr>
+          <p:cNvPr id="17" name="Text 15"/>
+          <p:cNvSpPr txBox="1"/>
+          <p:nvPr/>
+        </p:nvSpPr>
+        <p:spPr>
+          <a:xfrm>
+            <a:off x="457200" y="4315968"/>
+            <a:ext cx="8229600" cy="256032"/>
+          </a:xfrm>
+          <a:prstGeom prst="rect">
+            <a:avLst/>
+          </a:prstGeom>
+          <a:noFill/>
+          <a:ln/>
+        </p:spPr>
+        <p:txBody>
+          <a:bodyPr wrap="square" lIns="0" tIns="0" rIns="0" bIns="0" rtlCol="0" anchor="t"/>
+          <a:lstStyle/>
+          <a:p>
+            <a:pPr indent="0" marL="0">
+              <a:buNone/>
+            </a:pPr>
+            <a:r>
+              <a:rPr lang="en-US" sz="1100" b="1" dirty="0">
                 <a:solidFill>
                   <a:srgbClr val="F4F1EA"/>
                 </a:solidFill>
@@ -14273,7 +14351,7 @@
                 <a:ea typeface="Calibri" pitchFamily="34" charset="-122"/>
                 <a:cs typeface="Calibri" pitchFamily="34" charset="-120"/>
               </a:rPr>
-              <a:t>Repository (tag PRISM_GENAI_HACKATHON_Y2026) and 5-minute demo video: links in the submission form.</a:t>
+              <a:t>Shourya Chouhan  ·  Shreya Singh Chouhan  ·  Yash Mittal  ·  Vrunda Hatwar</a:t>
             </a:r>
             <a:endParaRPr lang="en-US" sz="1100" dirty="0"/>
           </a:p>
@@ -14281,30 +14359,30 @@
       </p:sp>
       <p:sp>
         <p:nvSpPr>
-          <p:cNvPr id="17" name="Text 15"/>
-          <p:cNvSpPr txBox="1"/>
-          <p:nvPr/>
-        </p:nvSpPr>
-        <p:spPr>
-          <a:xfrm>
-            <a:off x="457200" y="4343400"/>
-            <a:ext cx="8229600" cy="274320"/>
-          </a:xfrm>
-          <a:prstGeom prst="rect">
-            <a:avLst/>
-          </a:prstGeom>
-          <a:noFill/>
-          <a:ln/>
-        </p:spPr>
-        <p:txBody>
-          <a:bodyPr wrap="square" lIns="0" tIns="0" rIns="0" bIns="0" rtlCol="0" anchor="t"/>
-          <a:lstStyle/>
-          <a:p>
-            <a:pPr indent="0" marL="0">
-              <a:buNone/>
-            </a:pPr>
-            <a:r>
-              <a:rPr lang="en-US" sz="950" dirty="0">
+          <p:cNvPr id="18" name="Text 16"/>
+          <p:cNvSpPr txBox="1"/>
+          <p:nvPr/>
+        </p:nvSpPr>
+        <p:spPr>
+          <a:xfrm>
+            <a:off x="457200" y="4590288"/>
+            <a:ext cx="8229600" cy="256032"/>
+          </a:xfrm>
+          <a:prstGeom prst="rect">
+            <a:avLst/>
+          </a:prstGeom>
+          <a:noFill/>
+          <a:ln/>
+        </p:spPr>
+        <p:txBody>
+          <a:bodyPr wrap="square" lIns="0" tIns="0" rIns="0" bIns="0" rtlCol="0" anchor="t"/>
+          <a:lstStyle/>
+          <a:p>
+            <a:pPr indent="0" marL="0">
+              <a:buNone/>
+            </a:pPr>
+            <a:r>
+              <a:rPr lang="en-US" sz="900" dirty="0">
                 <a:solidFill>
                   <a:srgbClr val="A8A091"/>
                 </a:solidFill>
@@ -14314,7 +14392,7 @@
               </a:rPr>
               <a:t>Team Aloo Paratha  ·  M S Ramaiah Institute of Technology (MSRIT), Bengaluru</a:t>
             </a:r>
-            <a:endParaRPr lang="en-US" sz="950" dirty="0"/>
+            <a:endParaRPr lang="en-US" sz="900" dirty="0"/>
           </a:p>
         </p:txBody>
       </p:sp>

</xml_diff>